<commit_message>
fix: spawned sessions get no MCP servers unless asked for
The first real decomposition sat for ten minutes at 0.6% CPU. It was not
thinking: `claude -p` inherits whatever MCP servers the human has configured, and
it was waiting on `npm exec @playwright/mcp` — a browser automation server, for a
task with no browser in it.

Startup cost is the smaller half. The session was already running under
bypassPermissions, and inheriting the human's configuration hands an unattended
agent their mail, chat and design tools as well. Neither belongs to a job that
decomposes a requirement into issues.

--strict-mcp-config with no --mcp-config gives it none. Resume carries it too:
a resumed session is the same session, with the same reach.

Co-Authored-By: Claude Opus 5 (1M context) <noreply@anthropic.com>
</commit_message>
<xml_diff>
--- a/loop-on-issue-intro.pptx
+++ b/loop-on-issue-intro.pptx
@@ -1262,20 +1262,20 @@
       <p:grpSpPr/>
       <p:sp>
         <p:nvSpPr>
-          <p:cNvPr id="100009" name="Band"/>
+          <p:cNvPr id="100057" name="Band2"/>
           <p:cNvSpPr/>
           <p:nvPr/>
         </p:nvSpPr>
         <p:spPr>
           <a:xfrm xmlns:a="http://schemas.openxmlformats.org/drawingml/2006/main">
-            <a:off x="0" y="0"/>
-            <a:ext cx="198000" cy="6858000"/>
+            <a:off x="792000" y="5292000"/>
+            <a:ext cx="10861200" cy="972000"/>
           </a:xfrm>
           <a:prstGeom xmlns:a="http://schemas.openxmlformats.org/drawingml/2006/main" prst="rect">
             <a:avLst/>
           </a:prstGeom>
           <a:solidFill xmlns:a="http://schemas.openxmlformats.org/drawingml/2006/main">
-            <a:srgbClr val="02C39A"/>
+            <a:srgbClr val="F1F5F8"/>
           </a:solidFill>
           <a:ln xmlns:a="http://schemas.openxmlformats.org/drawingml/2006/main">
             <a:noFill/>
@@ -1971,27 +1971,27 @@
         </p:nvSpPr>
         <p:spPr>
           <a:xfrm xmlns:a="http://schemas.openxmlformats.org/drawingml/2006/main">
-            <a:off x="792000" y="5436000"/>
-            <a:ext cx="7200000" cy="324000"/>
-          </a:xfrm>
-          <a:prstGeom xmlns:a="http://schemas.openxmlformats.org/drawingml/2006/main" prst="rect">
-            <a:avLst/>
-          </a:prstGeom>
-          <a:noFill xmlns:a="http://schemas.openxmlformats.org/drawingml/2006/main"/>
-        </p:spPr>
-        <p:txBody>
-          <a:bodyPr xmlns:a="http://schemas.openxmlformats.org/drawingml/2006/main"/>
-          <a:lstStyle xmlns:a="http://schemas.openxmlformats.org/drawingml/2006/main"/>
-          <a:p xmlns:a="http://schemas.openxmlformats.org/drawingml/2006/main">
-            <a:r>
-              <a:rPr lang="en-US" sz="1400">
-                <a:solidFill>
-                  <a:srgbClr val="6B8FAA"/>
+            <a:off x="792000" y="3924000"/>
+            <a:ext cx="4212000" cy="1080000"/>
+          </a:xfrm>
+          <a:prstGeom xmlns:a="http://schemas.openxmlformats.org/drawingml/2006/main" prst="rect">
+            <a:avLst/>
+          </a:prstGeom>
+          <a:noFill xmlns:a="http://schemas.openxmlformats.org/drawingml/2006/main"/>
+        </p:spPr>
+        <p:txBody>
+          <a:bodyPr xmlns:a="http://schemas.openxmlformats.org/drawingml/2006/main"/>
+          <a:lstStyle xmlns:a="http://schemas.openxmlformats.org/drawingml/2006/main"/>
+          <a:p xmlns:a="http://schemas.openxmlformats.org/drawingml/2006/main">
+            <a:r>
+              <a:rPr lang="en-US" sz="1800">
+                <a:solidFill>
+                  <a:srgbClr val="4E6E88"/>
                 </a:solidFill>
                 <a:latin typeface="Consolas"/>
                 <a:ea typeface="Microsoft YaHei"/>
               </a:rPr>
-              <a:t>另有 [SKIP]：确认不需要改代码时才走，而且必须写明理由。</a:t>
+              <a:t>另有 [SKIP]：确认这个 issue 不需要改代码时才走，而且必须写明理由。</a:t>
             </a:r>
           </a:p>
         </p:txBody>
@@ -2122,6 +2122,213 @@
           </a:ln>
         </p:spPr>
       </p:cxnSp>
+      <p:sp>
+        <p:nvSpPr>
+          <p:cNvPr id="100058" name="TextBox 25"/>
+          <p:cNvSpPr/>
+          <p:nvPr/>
+        </p:nvSpPr>
+        <p:spPr>
+          <a:xfrm xmlns:a="http://schemas.openxmlformats.org/drawingml/2006/main">
+            <a:off x="1044000" y="5526000"/>
+            <a:ext cx="93600" cy="93600"/>
+          </a:xfrm>
+          <a:prstGeom xmlns:a="http://schemas.openxmlformats.org/drawingml/2006/main" prst="rect">
+            <a:avLst/>
+          </a:prstGeom>
+          <a:solidFill xmlns:a="http://schemas.openxmlformats.org/drawingml/2006/main">
+            <a:srgbClr val="02C39A"/>
+          </a:solidFill>
+          <a:ln xmlns:a="http://schemas.openxmlformats.org/drawingml/2006/main">
+            <a:noFill/>
+          </a:ln>
+        </p:spPr>
+        <p:txBody>
+          <a:bodyPr xmlns:a="http://schemas.openxmlformats.org/drawingml/2006/main"/>
+          <a:lstStyle xmlns:a="http://schemas.openxmlformats.org/drawingml/2006/main"/>
+          <a:p xmlns:a="http://schemas.openxmlformats.org/drawingml/2006/main"/>
+        </p:txBody>
+      </p:sp>
+      <p:sp>
+        <p:nvSpPr>
+          <p:cNvPr id="100059" name="TextBox 26"/>
+          <p:cNvSpPr txBox="1"/>
+          <p:nvPr/>
+        </p:nvSpPr>
+        <p:spPr>
+          <a:xfrm xmlns:a="http://schemas.openxmlformats.org/drawingml/2006/main">
+            <a:off x="1242000" y="5454000"/>
+            <a:ext cx="3060000" cy="684000"/>
+          </a:xfrm>
+          <a:prstGeom xmlns:a="http://schemas.openxmlformats.org/drawingml/2006/main" prst="rect">
+            <a:avLst/>
+          </a:prstGeom>
+          <a:noFill xmlns:a="http://schemas.openxmlformats.org/drawingml/2006/main"/>
+        </p:spPr>
+        <p:txBody>
+          <a:bodyPr xmlns:a="http://schemas.openxmlformats.org/drawingml/2006/main"/>
+          <a:lstStyle xmlns:a="http://schemas.openxmlformats.org/drawingml/2006/main"/>
+          <a:p xmlns:a="http://schemas.openxmlformats.org/drawingml/2006/main">
+            <a:r>
+              <a:rPr lang="en-US" sz="1800">
+                <a:solidFill>
+                  <a:srgbClr val="2B3A4E"/>
+                </a:solidFill>
+                <a:latin typeface="Calibri"/>
+                <a:ea typeface="Microsoft YaHei"/>
+              </a:rPr>
+              <a:t>每个 issue 一个独立 worktree，默认最多 2 个并行</a:t>
+            </a:r>
+          </a:p>
+        </p:txBody>
+      </p:sp>
+      <p:sp>
+        <p:nvSpPr>
+          <p:cNvPr id="100060" name="TextBox 27"/>
+          <p:cNvSpPr/>
+          <p:nvPr/>
+        </p:nvSpPr>
+        <p:spPr>
+          <a:xfrm xmlns:a="http://schemas.openxmlformats.org/drawingml/2006/main">
+            <a:off x="4593600" y="5526000"/>
+            <a:ext cx="93600" cy="93600"/>
+          </a:xfrm>
+          <a:prstGeom xmlns:a="http://schemas.openxmlformats.org/drawingml/2006/main" prst="rect">
+            <a:avLst/>
+          </a:prstGeom>
+          <a:solidFill xmlns:a="http://schemas.openxmlformats.org/drawingml/2006/main">
+            <a:srgbClr val="02C39A"/>
+          </a:solidFill>
+          <a:ln xmlns:a="http://schemas.openxmlformats.org/drawingml/2006/main">
+            <a:noFill/>
+          </a:ln>
+        </p:spPr>
+        <p:txBody>
+          <a:bodyPr xmlns:a="http://schemas.openxmlformats.org/drawingml/2006/main"/>
+          <a:lstStyle xmlns:a="http://schemas.openxmlformats.org/drawingml/2006/main"/>
+          <a:p xmlns:a="http://schemas.openxmlformats.org/drawingml/2006/main"/>
+        </p:txBody>
+      </p:sp>
+      <p:sp>
+        <p:nvSpPr>
+          <p:cNvPr id="100061" name="TextBox 28"/>
+          <p:cNvSpPr txBox="1"/>
+          <p:nvPr/>
+        </p:nvSpPr>
+        <p:spPr>
+          <a:xfrm xmlns:a="http://schemas.openxmlformats.org/drawingml/2006/main">
+            <a:off x="4791600" y="5454000"/>
+            <a:ext cx="3060000" cy="684000"/>
+          </a:xfrm>
+          <a:prstGeom xmlns:a="http://schemas.openxmlformats.org/drawingml/2006/main" prst="rect">
+            <a:avLst/>
+          </a:prstGeom>
+          <a:noFill xmlns:a="http://schemas.openxmlformats.org/drawingml/2006/main"/>
+        </p:spPr>
+        <p:txBody>
+          <a:bodyPr xmlns:a="http://schemas.openxmlformats.org/drawingml/2006/main"/>
+          <a:lstStyle xmlns:a="http://schemas.openxmlformats.org/drawingml/2006/main"/>
+          <a:p xmlns:a="http://schemas.openxmlformats.org/drawingml/2006/main">
+            <a:r>
+              <a:rPr lang="en-US" sz="1800">
+                <a:solidFill>
+                  <a:srgbClr val="2B3A4E"/>
+                </a:solidFill>
+                <a:latin typeface="Calibri"/>
+                <a:ea typeface="Microsoft YaHei"/>
+              </a:rPr>
+              <a:t>每一步的进度都写成 issue 评论，人随时能接管</a:t>
+            </a:r>
+          </a:p>
+        </p:txBody>
+      </p:sp>
+      <p:sp>
+        <p:nvSpPr>
+          <p:cNvPr id="100062" name="TextBox 29"/>
+          <p:cNvSpPr/>
+          <p:nvPr/>
+        </p:nvSpPr>
+        <p:spPr>
+          <a:xfrm xmlns:a="http://schemas.openxmlformats.org/drawingml/2006/main">
+            <a:off x="8143200" y="5526000"/>
+            <a:ext cx="93600" cy="93600"/>
+          </a:xfrm>
+          <a:prstGeom xmlns:a="http://schemas.openxmlformats.org/drawingml/2006/main" prst="rect">
+            <a:avLst/>
+          </a:prstGeom>
+          <a:solidFill xmlns:a="http://schemas.openxmlformats.org/drawingml/2006/main">
+            <a:srgbClr val="02C39A"/>
+          </a:solidFill>
+          <a:ln xmlns:a="http://schemas.openxmlformats.org/drawingml/2006/main">
+            <a:noFill/>
+          </a:ln>
+        </p:spPr>
+        <p:txBody>
+          <a:bodyPr xmlns:a="http://schemas.openxmlformats.org/drawingml/2006/main"/>
+          <a:lstStyle xmlns:a="http://schemas.openxmlformats.org/drawingml/2006/main"/>
+          <a:p xmlns:a="http://schemas.openxmlformats.org/drawingml/2006/main"/>
+        </p:txBody>
+      </p:sp>
+      <p:sp>
+        <p:nvSpPr>
+          <p:cNvPr id="100063" name="TextBox 30"/>
+          <p:cNvSpPr txBox="1"/>
+          <p:nvPr/>
+        </p:nvSpPr>
+        <p:spPr>
+          <a:xfrm xmlns:a="http://schemas.openxmlformats.org/drawingml/2006/main">
+            <a:off x="8341200" y="5454000"/>
+            <a:ext cx="3060000" cy="684000"/>
+          </a:xfrm>
+          <a:prstGeom xmlns:a="http://schemas.openxmlformats.org/drawingml/2006/main" prst="rect">
+            <a:avLst/>
+          </a:prstGeom>
+          <a:noFill xmlns:a="http://schemas.openxmlformats.org/drawingml/2006/main"/>
+        </p:spPr>
+        <p:txBody>
+          <a:bodyPr xmlns:a="http://schemas.openxmlformats.org/drawingml/2006/main"/>
+          <a:lstStyle xmlns:a="http://schemas.openxmlformats.org/drawingml/2006/main"/>
+          <a:p xmlns:a="http://schemas.openxmlformats.org/drawingml/2006/main">
+            <a:r>
+              <a:rPr lang="en-US" sz="1800">
+                <a:solidFill>
+                  <a:srgbClr val="2B3A4E"/>
+                </a:solidFill>
+                <a:latin typeface="Calibri"/>
+                <a:ea typeface="Microsoft YaHei"/>
+              </a:rPr>
+              <a:t>提交前先跑这个仓库自己的 verify_command</a:t>
+            </a:r>
+          </a:p>
+        </p:txBody>
+      </p:sp>
+      <p:sp>
+        <p:nvSpPr>
+          <p:cNvPr id="100009" name="Band"/>
+          <p:cNvSpPr/>
+          <p:nvPr/>
+        </p:nvSpPr>
+        <p:spPr>
+          <a:xfrm xmlns:a="http://schemas.openxmlformats.org/drawingml/2006/main">
+            <a:off x="0" y="0"/>
+            <a:ext cx="198000" cy="6858000"/>
+          </a:xfrm>
+          <a:prstGeom xmlns:a="http://schemas.openxmlformats.org/drawingml/2006/main" prst="rect">
+            <a:avLst/>
+          </a:prstGeom>
+          <a:solidFill xmlns:a="http://schemas.openxmlformats.org/drawingml/2006/main">
+            <a:srgbClr val="02C39A"/>
+          </a:solidFill>
+          <a:ln xmlns:a="http://schemas.openxmlformats.org/drawingml/2006/main">
+            <a:noFill/>
+          </a:ln>
+        </p:spPr>
+        <p:txBody>
+          <a:bodyPr xmlns:a="http://schemas.openxmlformats.org/drawingml/2006/main"/>
+          <a:lstStyle xmlns:a="http://schemas.openxmlformats.org/drawingml/2006/main"/>
+          <a:p xmlns:a="http://schemas.openxmlformats.org/drawingml/2006/main"/>
+        </p:txBody>
+      </p:sp>
     </p:spTree>
   </p:cSld>
 </p:sld>

</xml_diff>

<commit_message>
fix: a retry resumes its session instead of colliding with it
Deriving the session id from the request id makes it recomputable, which was the
point — but a derived id can only be *created* once. The retry ran
`claude -p --session-id <derived>` against the session its own first attempt had
left behind and died on "Session ID is already in use" before doing anything.

Anything past the first attempt now resumes. That is the better behaviour anyway,
not just the working one: the earlier attempt had already read the repository and
drafted three issues, and starting over pays for that twice and invites a
different conclusion. The retry prompt is deliberately short for the same reason —
the session already holds the brief.

Found because the evidence check from two commits ago did its job: the run was
recorded as failed with the reason, where before it would have been another
confident `done` with nothing behind it.

Co-Authored-By: Claude Opus 5 (1M context) <noreply@anthropic.com>
</commit_message>
<xml_diff>
--- a/loop-on-issue-intro.pptx
+++ b/loop-on-issue-intro.pptx
@@ -2130,7 +2130,7 @@
         </p:nvSpPr>
         <p:spPr>
           <a:xfrm xmlns:a="http://schemas.openxmlformats.org/drawingml/2006/main">
-            <a:off x="1044000" y="5526000"/>
+            <a:off x="1044000" y="5544000"/>
             <a:ext cx="93600" cy="93600"/>
           </a:xfrm>
           <a:prstGeom xmlns:a="http://schemas.openxmlformats.org/drawingml/2006/main" prst="rect">
@@ -2157,8 +2157,8 @@
         </p:nvSpPr>
         <p:spPr>
           <a:xfrm xmlns:a="http://schemas.openxmlformats.org/drawingml/2006/main">
-            <a:off x="1242000" y="5454000"/>
-            <a:ext cx="3060000" cy="684000"/>
+            <a:off x="1242000" y="5472000"/>
+            <a:ext cx="3060000" cy="648000"/>
           </a:xfrm>
           <a:prstGeom xmlns:a="http://schemas.openxmlformats.org/drawingml/2006/main" prst="rect">
             <a:avLst/>
@@ -2177,7 +2177,7 @@
                 <a:latin typeface="Calibri"/>
                 <a:ea typeface="Microsoft YaHei"/>
               </a:rPr>
-              <a:t>每个 issue 一个独立 worktree，默认最多 2 个并行</a:t>
+              <a:t>每个 issue 独占一个 worktree</a:t>
             </a:r>
           </a:p>
         </p:txBody>
@@ -2190,7 +2190,7 @@
         </p:nvSpPr>
         <p:spPr>
           <a:xfrm xmlns:a="http://schemas.openxmlformats.org/drawingml/2006/main">
-            <a:off x="4593600" y="5526000"/>
+            <a:off x="4593600" y="5544000"/>
             <a:ext cx="93600" cy="93600"/>
           </a:xfrm>
           <a:prstGeom xmlns:a="http://schemas.openxmlformats.org/drawingml/2006/main" prst="rect">
@@ -2217,8 +2217,8 @@
         </p:nvSpPr>
         <p:spPr>
           <a:xfrm xmlns:a="http://schemas.openxmlformats.org/drawingml/2006/main">
-            <a:off x="4791600" y="5454000"/>
-            <a:ext cx="3060000" cy="684000"/>
+            <a:off x="4791600" y="5472000"/>
+            <a:ext cx="3060000" cy="648000"/>
           </a:xfrm>
           <a:prstGeom xmlns:a="http://schemas.openxmlformats.org/drawingml/2006/main" prst="rect">
             <a:avLst/>
@@ -2250,7 +2250,7 @@
         </p:nvSpPr>
         <p:spPr>
           <a:xfrm xmlns:a="http://schemas.openxmlformats.org/drawingml/2006/main">
-            <a:off x="8143200" y="5526000"/>
+            <a:off x="8143200" y="5544000"/>
             <a:ext cx="93600" cy="93600"/>
           </a:xfrm>
           <a:prstGeom xmlns:a="http://schemas.openxmlformats.org/drawingml/2006/main" prst="rect">
@@ -2277,8 +2277,8 @@
         </p:nvSpPr>
         <p:spPr>
           <a:xfrm xmlns:a="http://schemas.openxmlformats.org/drawingml/2006/main">
-            <a:off x="8341200" y="5454000"/>
-            <a:ext cx="3060000" cy="684000"/>
+            <a:off x="8341200" y="5472000"/>
+            <a:ext cx="3060000" cy="648000"/>
           </a:xfrm>
           <a:prstGeom xmlns:a="http://schemas.openxmlformats.org/drawingml/2006/main" prst="rect">
             <a:avLst/>

</xml_diff>